<commit_message>
Reframe Phase 2 as a diagnosed negative result in report and deck
The Stage-2 run shows the STACD causal matrix never moves from its
initialization (mean 0.267/std 0.048 vs init 0.269/0.048; |dA| 0.005 per
entry over 12 epochs; prediction head near 0.5). Report and deck now
present this honestly:

- report: new "Phase 2: The Causal Graph Does Not Learn" results
  subsection with the three diagnostic measurements; abstract, intro,
  conclusion and limitations reworded from "learns a graph" to an
  end-to-end audit; the false "top edges as event chains" claim removed.
- deck: slide 13 rebuilt around the real causal-matrix figure and the
  diagnosis, replacing the fabricated M1->C1 / C1->K1 edge weights;
  discussion slide and title-card claims corrected.

The unifying point: the same weak forward-time signal that collapses
chronological prediction also starves the causal-discovery gradient.

https://claude.ai/code/session_01PQFYRmKHxnZj3rJSKXw8x3
</commit_message>
<xml_diff>
--- a/DirectionA/docs/final-deck/EventChain_CS173_Final.pptx
+++ b/DirectionA/docs/final-deck/EventChain_CS173_Final.pptx
@@ -3619,7 +3619,7 @@
                 </a:solidFill>
                 <a:latin typeface="Calibri"/>
               </a:rPr>
-              <a:t>20×20 event-type causal graph with lags</a:t>
+              <a:t>structured events + transparent tabular model</a:t>
             </a:r>
           </a:p>
         </p:txBody>
@@ -7308,7 +7308,7 @@
                 </a:solidFill>
                 <a:latin typeface="Calibri"/>
               </a:rPr>
-              <a:t>Interpretability Product — Event Chains</a:t>
+              <a:t>Phase 2 Result — The Causal Graph Did Not Learn</a:t>
             </a:r>
           </a:p>
         </p:txBody>
@@ -7405,7 +7405,7 @@
         </p:nvSpPr>
         <p:spPr>
           <a:xfrm>
-            <a:off x="548640" y="1280160"/>
+            <a:off x="548640" y="1234440"/>
             <a:ext cx="10972800" cy="365760"/>
           </a:xfrm>
           <a:prstGeom prst="rect">
@@ -7428,33 +7428,57 @@
               </a:spcAft>
             </a:pPr>
             <a:r>
-              <a:rPr sz="1300" b="0" i="0">
+              <a:rPr sz="1250" b="0" i="0">
                 <a:solidFill>
                   <a:srgbClr val="243748"/>
                 </a:solidFill>
                 <a:latin typeface="Calibri"/>
               </a:rPr>
-              <a:t>The learned graph is read as directed event chains with explicit lags. Designed-for chains:</a:t>
-            </a:r>
-          </a:p>
-        </p:txBody>
-      </p:sp>
-      <p:sp>
-        <p:nvSpPr>
-          <p:cNvPr id="9" name="Rounded Rectangle 8"/>
+              <a:t>STACD trained 12 epochs on 9,527 real event sequences — a clear, honestly-reported negative result:</a:t>
+            </a:r>
+          </a:p>
+        </p:txBody>
+      </p:sp>
+      <p:pic>
+        <p:nvPicPr>
+          <p:cNvPr id="9" name="Picture 8" descr="fig_causal_matrix.png"/>
+          <p:cNvPicPr>
+            <a:picLocks noChangeAspect="1"/>
+          </p:cNvPicPr>
+          <p:nvPr/>
+        </p:nvPicPr>
+        <p:blipFill>
+          <a:blip r:embed="rId2"/>
+          <a:stretch>
+            <a:fillRect/>
+          </a:stretch>
+        </p:blipFill>
+        <p:spPr>
+          <a:xfrm>
+            <a:off x="457200" y="1783080"/>
+            <a:ext cx="3246120" cy="1384916"/>
+          </a:xfrm>
+          <a:prstGeom prst="rect">
+            <a:avLst/>
+          </a:prstGeom>
+        </p:spPr>
+      </p:pic>
+      <p:sp>
+        <p:nvSpPr>
+          <p:cNvPr id="10" name="Rounded Rectangle 9"/>
           <p:cNvSpPr/>
           <p:nvPr/>
         </p:nvSpPr>
         <p:spPr>
           <a:xfrm>
-            <a:off x="640080" y="1783080"/>
-            <a:ext cx="3108960" cy="548640"/>
+            <a:off x="7589520" y="1691640"/>
+            <a:ext cx="4114800" cy="4069080"/>
           </a:xfrm>
           <a:prstGeom prst="roundRect">
             <a:avLst/>
           </a:prstGeom>
           <a:solidFill>
-            <a:srgbClr val="1D3A5F"/>
+            <a:srgbClr val="EEF2F7"/>
           </a:solidFill>
           <a:ln>
             <a:noFill/>
@@ -7485,27 +7509,27 @@
       </p:sp>
       <p:sp>
         <p:nvSpPr>
-          <p:cNvPr id="10" name="TextBox 9"/>
-          <p:cNvSpPr txBox="1"/>
-          <p:nvPr/>
-        </p:nvSpPr>
-        <p:spPr>
-          <a:xfrm>
-            <a:off x="640080" y="1901952"/>
-            <a:ext cx="3108960" cy="365760"/>
-          </a:xfrm>
-          <a:prstGeom prst="rect">
-            <a:avLst/>
-          </a:prstGeom>
-          <a:noFill/>
-        </p:spPr>
-        <p:txBody>
-          <a:bodyPr wrap="square" anchor="t">
-            <a:spAutoFit/>
-          </a:bodyPr>
-          <a:lstStyle/>
-          <a:p>
-            <a:pPr algn="ctr">
+          <p:cNvPr id="11" name="TextBox 10"/>
+          <p:cNvSpPr txBox="1"/>
+          <p:nvPr/>
+        </p:nvSpPr>
+        <p:spPr>
+          <a:xfrm>
+            <a:off x="7818120" y="1828800"/>
+            <a:ext cx="3703320" cy="365760"/>
+          </a:xfrm>
+          <a:prstGeom prst="rect">
+            <a:avLst/>
+          </a:prstGeom>
+          <a:noFill/>
+        </p:spPr>
+        <p:txBody>
+          <a:bodyPr wrap="square" anchor="t">
+            <a:spAutoFit/>
+          </a:bodyPr>
+          <a:lstStyle/>
+          <a:p>
+            <a:pPr algn="l">
               <a:spcBef>
                 <a:spcPts val="0"/>
               </a:spcBef>
@@ -7514,965 +7538,174 @@
               </a:spcAft>
             </a:pPr>
             <a:r>
-              <a:rPr sz="1150" b="1" i="0">
-                <a:solidFill>
-                  <a:srgbClr val="FFFFFF"/>
-                </a:solidFill>
-                <a:latin typeface="Calibri"/>
-              </a:rPr>
-              <a:t>M1 Interest Rate</a:t>
-            </a:r>
-          </a:p>
-        </p:txBody>
-      </p:sp>
-      <p:sp>
-        <p:nvSpPr>
-          <p:cNvPr id="11" name="TextBox 10"/>
-          <p:cNvSpPr txBox="1"/>
-          <p:nvPr/>
-        </p:nvSpPr>
-        <p:spPr>
-          <a:xfrm>
-            <a:off x="3794760" y="1874519"/>
-            <a:ext cx="640080" cy="365760"/>
-          </a:xfrm>
-          <a:prstGeom prst="rect">
-            <a:avLst/>
-          </a:prstGeom>
-          <a:noFill/>
-        </p:spPr>
-        <p:txBody>
-          <a:bodyPr wrap="square" anchor="t">
-            <a:spAutoFit/>
-          </a:bodyPr>
-          <a:lstStyle/>
-          <a:p>
-            <a:pPr algn="ctr">
-              <a:spcBef>
-                <a:spcPts val="0"/>
-              </a:spcBef>
-              <a:spcAft>
-                <a:spcPts val="400"/>
-              </a:spcAft>
-            </a:pPr>
-            <a:r>
-              <a:rPr sz="1800" b="1" i="0">
+              <a:rPr sz="1200" b="1" i="0">
+                <a:solidFill>
+                  <a:srgbClr val="C2492F"/>
+                </a:solidFill>
+                <a:latin typeface="Calibri"/>
+              </a:rPr>
+              <a:t>DIAGNOSED NEGATIVE RESULT</a:t>
+            </a:r>
+          </a:p>
+        </p:txBody>
+      </p:sp>
+      <p:sp>
+        <p:nvSpPr>
+          <p:cNvPr id="12" name="TextBox 11"/>
+          <p:cNvSpPr txBox="1"/>
+          <p:nvPr/>
+        </p:nvSpPr>
+        <p:spPr>
+          <a:xfrm>
+            <a:off x="7818120" y="2240280"/>
+            <a:ext cx="3749039" cy="3474720"/>
+          </a:xfrm>
+          <a:prstGeom prst="rect">
+            <a:avLst/>
+          </a:prstGeom>
+          <a:noFill/>
+        </p:spPr>
+        <p:txBody>
+          <a:bodyPr wrap="square" anchor="t">
+            <a:spAutoFit/>
+          </a:bodyPr>
+          <a:lstStyle/>
+          <a:p>
+            <a:pPr algn="l">
+              <a:lnSpc>
+                <a:spcPct val="112000"/>
+              </a:lnSpc>
+              <a:spcBef>
+                <a:spcPts val="0"/>
+              </a:spcBef>
+              <a:spcAft>
+                <a:spcPts val="700"/>
+              </a:spcAft>
+            </a:pPr>
+            <a:r>
+              <a:rPr sz="1100" b="1" i="0">
                 <a:solidFill>
                   <a:srgbClr val="E3861F"/>
                 </a:solidFill>
                 <a:latin typeface="Calibri"/>
               </a:rPr>
-              <a:t>→</a:t>
-            </a:r>
-          </a:p>
-        </p:txBody>
-      </p:sp>
-      <p:sp>
-        <p:nvSpPr>
-          <p:cNvPr id="12" name="Rounded Rectangle 11"/>
+              <a:t>▪  </a:t>
+            </a:r>
+            <a:r>
+              <a:rPr sz="1100" b="0" i="0">
+                <a:solidFill>
+                  <a:srgbClr val="243748"/>
+                </a:solidFill>
+                <a:latin typeface="Calibri"/>
+              </a:rPr>
+              <a:t>Trained A: mean 0.267, std 0.048 — identical to its initialization (0.269 / 0.048).</a:t>
+            </a:r>
+          </a:p>
+          <a:p>
+            <a:pPr algn="l">
+              <a:lnSpc>
+                <a:spcPct val="112000"/>
+              </a:lnSpc>
+              <a:spcBef>
+                <a:spcPts val="0"/>
+              </a:spcBef>
+              <a:spcAft>
+                <a:spcPts val="700"/>
+              </a:spcAft>
+            </a:pPr>
+            <a:r>
+              <a:rPr sz="1100" b="1" i="0">
+                <a:solidFill>
+                  <a:srgbClr val="E3861F"/>
+                </a:solidFill>
+                <a:latin typeface="Calibri"/>
+              </a:rPr>
+              <a:t>▪  </a:t>
+            </a:r>
+            <a:r>
+              <a:rPr sz="1100" b="0" i="0">
+                <a:solidFill>
+                  <a:srgbClr val="243748"/>
+                </a:solidFill>
+                <a:latin typeface="Calibri"/>
+              </a:rPr>
+              <a:t>Across 12 epochs A barely moves (mean change 0.005 per entry).</a:t>
+            </a:r>
+          </a:p>
+          <a:p>
+            <a:pPr algn="l">
+              <a:lnSpc>
+                <a:spcPct val="112000"/>
+              </a:lnSpc>
+              <a:spcBef>
+                <a:spcPts val="0"/>
+              </a:spcBef>
+              <a:spcAft>
+                <a:spcPts val="700"/>
+              </a:spcAft>
+            </a:pPr>
+            <a:r>
+              <a:rPr sz="1100" b="1" i="0">
+                <a:solidFill>
+                  <a:srgbClr val="E3861F"/>
+                </a:solidFill>
+                <a:latin typeface="Calibri"/>
+              </a:rPr>
+              <a:t>▪  </a:t>
+            </a:r>
+            <a:r>
+              <a:rPr sz="1100" b="0" i="0">
+                <a:solidFill>
+                  <a:srgbClr val="243748"/>
+                </a:solidFill>
+                <a:latin typeface="Calibri"/>
+              </a:rPr>
+              <a:t>STACD prediction head ≈ 0.5 (random) — almost no gradient reaches the graph.</a:t>
+            </a:r>
+          </a:p>
+          <a:p>
+            <a:pPr algn="l">
+              <a:lnSpc>
+                <a:spcPct val="112000"/>
+              </a:lnSpc>
+              <a:spcBef>
+                <a:spcPts val="0"/>
+              </a:spcBef>
+              <a:spcAft>
+                <a:spcPts val="700"/>
+              </a:spcAft>
+            </a:pPr>
+            <a:r>
+              <a:rPr sz="1100" b="1" i="0">
+                <a:solidFill>
+                  <a:srgbClr val="6B7785"/>
+                </a:solidFill>
+                <a:latin typeface="Calibri"/>
+              </a:rPr>
+              <a:t>      </a:t>
+            </a:r>
+            <a:r>
+              <a:rPr sz="950" b="1" i="0">
+                <a:solidFill>
+                  <a:srgbClr val="1D3A5F"/>
+                </a:solidFill>
+                <a:latin typeface="Calibri"/>
+              </a:rPr>
+              <a:t>→ same weak forward signal as the chronological collapse</a:t>
+            </a:r>
+          </a:p>
+        </p:txBody>
+      </p:sp>
+      <p:sp>
+        <p:nvSpPr>
+          <p:cNvPr id="13" name="Rounded Rectangle 12"/>
           <p:cNvSpPr/>
           <p:nvPr/>
         </p:nvSpPr>
         <p:spPr>
           <a:xfrm>
-            <a:off x="4480560" y="1783080"/>
-            <a:ext cx="3108960" cy="548640"/>
-          </a:xfrm>
-          <a:prstGeom prst="roundRect">
-            <a:avLst/>
-          </a:prstGeom>
-          <a:solidFill>
-            <a:srgbClr val="2E6F9E"/>
-          </a:solidFill>
-          <a:ln>
-            <a:noFill/>
-          </a:ln>
-          <a:effectLst/>
-        </p:spPr>
-        <p:style>
-          <a:lnRef idx="1">
-            <a:schemeClr val="accent1"/>
-          </a:lnRef>
-          <a:fillRef idx="3">
-            <a:schemeClr val="accent1"/>
-          </a:fillRef>
-          <a:effectRef idx="2">
-            <a:schemeClr val="accent1"/>
-          </a:effectRef>
-          <a:fontRef idx="minor">
-            <a:schemeClr val="lt1"/>
-          </a:fontRef>
-        </p:style>
-        <p:txBody>
-          <a:bodyPr rtlCol="0" anchor="ctr"/>
-          <a:lstStyle/>
-          <a:p>
-            <a:pPr algn="ctr"/>
-          </a:p>
-        </p:txBody>
-      </p:sp>
-      <p:sp>
-        <p:nvSpPr>
-          <p:cNvPr id="13" name="TextBox 12"/>
-          <p:cNvSpPr txBox="1"/>
-          <p:nvPr/>
-        </p:nvSpPr>
-        <p:spPr>
-          <a:xfrm>
-            <a:off x="4480560" y="1901952"/>
-            <a:ext cx="3108960" cy="365760"/>
-          </a:xfrm>
-          <a:prstGeom prst="rect">
-            <a:avLst/>
-          </a:prstGeom>
-          <a:noFill/>
-        </p:spPr>
-        <p:txBody>
-          <a:bodyPr wrap="square" anchor="t">
-            <a:spAutoFit/>
-          </a:bodyPr>
-          <a:lstStyle/>
-          <a:p>
-            <a:pPr algn="ctr">
-              <a:spcBef>
-                <a:spcPts val="0"/>
-              </a:spcBef>
-              <a:spcAft>
-                <a:spcPts val="400"/>
-              </a:spcAft>
-            </a:pPr>
-            <a:r>
-              <a:rPr sz="1150" b="1" i="0">
-                <a:solidFill>
-                  <a:srgbClr val="FFFFFF"/>
-                </a:solidFill>
-                <a:latin typeface="Calibri"/>
-              </a:rPr>
-              <a:t>C1 Earnings</a:t>
-            </a:r>
-          </a:p>
-        </p:txBody>
-      </p:sp>
-      <p:sp>
-        <p:nvSpPr>
-          <p:cNvPr id="14" name="TextBox 13"/>
-          <p:cNvSpPr txBox="1"/>
-          <p:nvPr/>
-        </p:nvSpPr>
-        <p:spPr>
-          <a:xfrm>
-            <a:off x="7772400" y="1901952"/>
-            <a:ext cx="3840480" cy="365760"/>
-          </a:xfrm>
-          <a:prstGeom prst="rect">
-            <a:avLst/>
-          </a:prstGeom>
-          <a:noFill/>
-        </p:spPr>
-        <p:txBody>
-          <a:bodyPr wrap="square" anchor="t">
-            <a:spAutoFit/>
-          </a:bodyPr>
-          <a:lstStyle/>
-          <a:p>
-            <a:pPr algn="l">
-              <a:spcBef>
-                <a:spcPts val="0"/>
-              </a:spcBef>
-              <a:spcAft>
-                <a:spcPts val="400"/>
-              </a:spcAft>
-            </a:pPr>
-            <a:r>
-              <a:rPr sz="1100" b="0" i="1">
-                <a:solidFill>
-                  <a:srgbClr val="6B7785"/>
-                </a:solidFill>
-                <a:latin typeface="Calibri"/>
-              </a:rPr>
-              <a:t>rate moves squeeze earnings</a:t>
-            </a:r>
-          </a:p>
-        </p:txBody>
-      </p:sp>
-      <p:sp>
-        <p:nvSpPr>
-          <p:cNvPr id="15" name="Rounded Rectangle 14"/>
-          <p:cNvSpPr/>
-          <p:nvPr/>
-        </p:nvSpPr>
-        <p:spPr>
-          <a:xfrm>
-            <a:off x="640080" y="2551176"/>
-            <a:ext cx="3108960" cy="548640"/>
-          </a:xfrm>
-          <a:prstGeom prst="roundRect">
-            <a:avLst/>
-          </a:prstGeom>
-          <a:solidFill>
-            <a:srgbClr val="1D3A5F"/>
-          </a:solidFill>
-          <a:ln>
-            <a:noFill/>
-          </a:ln>
-          <a:effectLst/>
-        </p:spPr>
-        <p:style>
-          <a:lnRef idx="1">
-            <a:schemeClr val="accent1"/>
-          </a:lnRef>
-          <a:fillRef idx="3">
-            <a:schemeClr val="accent1"/>
-          </a:fillRef>
-          <a:effectRef idx="2">
-            <a:schemeClr val="accent1"/>
-          </a:effectRef>
-          <a:fontRef idx="minor">
-            <a:schemeClr val="lt1"/>
-          </a:fontRef>
-        </p:style>
-        <p:txBody>
-          <a:bodyPr rtlCol="0" anchor="ctr"/>
-          <a:lstStyle/>
-          <a:p>
-            <a:pPr algn="ctr"/>
-          </a:p>
-        </p:txBody>
-      </p:sp>
-      <p:sp>
-        <p:nvSpPr>
-          <p:cNvPr id="16" name="TextBox 15"/>
-          <p:cNvSpPr txBox="1"/>
-          <p:nvPr/>
-        </p:nvSpPr>
-        <p:spPr>
-          <a:xfrm>
-            <a:off x="640080" y="2670048"/>
-            <a:ext cx="3108960" cy="365760"/>
-          </a:xfrm>
-          <a:prstGeom prst="rect">
-            <a:avLst/>
-          </a:prstGeom>
-          <a:noFill/>
-        </p:spPr>
-        <p:txBody>
-          <a:bodyPr wrap="square" anchor="t">
-            <a:spAutoFit/>
-          </a:bodyPr>
-          <a:lstStyle/>
-          <a:p>
-            <a:pPr algn="ctr">
-              <a:spcBef>
-                <a:spcPts val="0"/>
-              </a:spcBef>
-              <a:spcAft>
-                <a:spcPts val="400"/>
-              </a:spcAft>
-            </a:pPr>
-            <a:r>
-              <a:rPr sz="1150" b="1" i="0">
-                <a:solidFill>
-                  <a:srgbClr val="FFFFFF"/>
-                </a:solidFill>
-                <a:latin typeface="Calibri"/>
-              </a:rPr>
-              <a:t>C1 Earnings</a:t>
-            </a:r>
-          </a:p>
-        </p:txBody>
-      </p:sp>
-      <p:sp>
-        <p:nvSpPr>
-          <p:cNvPr id="17" name="TextBox 16"/>
-          <p:cNvSpPr txBox="1"/>
-          <p:nvPr/>
-        </p:nvSpPr>
-        <p:spPr>
-          <a:xfrm>
-            <a:off x="3794760" y="2642616"/>
-            <a:ext cx="640080" cy="365760"/>
-          </a:xfrm>
-          <a:prstGeom prst="rect">
-            <a:avLst/>
-          </a:prstGeom>
-          <a:noFill/>
-        </p:spPr>
-        <p:txBody>
-          <a:bodyPr wrap="square" anchor="t">
-            <a:spAutoFit/>
-          </a:bodyPr>
-          <a:lstStyle/>
-          <a:p>
-            <a:pPr algn="ctr">
-              <a:spcBef>
-                <a:spcPts val="0"/>
-              </a:spcBef>
-              <a:spcAft>
-                <a:spcPts val="400"/>
-              </a:spcAft>
-            </a:pPr>
-            <a:r>
-              <a:rPr sz="1800" b="1" i="0">
-                <a:solidFill>
-                  <a:srgbClr val="E3861F"/>
-                </a:solidFill>
-                <a:latin typeface="Calibri"/>
-              </a:rPr>
-              <a:t>→</a:t>
-            </a:r>
-          </a:p>
-        </p:txBody>
-      </p:sp>
-      <p:sp>
-        <p:nvSpPr>
-          <p:cNvPr id="18" name="Rounded Rectangle 17"/>
-          <p:cNvSpPr/>
-          <p:nvPr/>
-        </p:nvSpPr>
-        <p:spPr>
-          <a:xfrm>
-            <a:off x="4480560" y="2551176"/>
-            <a:ext cx="3108960" cy="548640"/>
-          </a:xfrm>
-          <a:prstGeom prst="roundRect">
-            <a:avLst/>
-          </a:prstGeom>
-          <a:solidFill>
-            <a:srgbClr val="2E6F9E"/>
-          </a:solidFill>
-          <a:ln>
-            <a:noFill/>
-          </a:ln>
-          <a:effectLst/>
-        </p:spPr>
-        <p:style>
-          <a:lnRef idx="1">
-            <a:schemeClr val="accent1"/>
-          </a:lnRef>
-          <a:fillRef idx="3">
-            <a:schemeClr val="accent1"/>
-          </a:fillRef>
-          <a:effectRef idx="2">
-            <a:schemeClr val="accent1"/>
-          </a:effectRef>
-          <a:fontRef idx="minor">
-            <a:schemeClr val="lt1"/>
-          </a:fontRef>
-        </p:style>
-        <p:txBody>
-          <a:bodyPr rtlCol="0" anchor="ctr"/>
-          <a:lstStyle/>
-          <a:p>
-            <a:pPr algn="ctr"/>
-          </a:p>
-        </p:txBody>
-      </p:sp>
-      <p:sp>
-        <p:nvSpPr>
-          <p:cNvPr id="19" name="TextBox 18"/>
-          <p:cNvSpPr txBox="1"/>
-          <p:nvPr/>
-        </p:nvSpPr>
-        <p:spPr>
-          <a:xfrm>
-            <a:off x="4480560" y="2670048"/>
-            <a:ext cx="3108960" cy="365760"/>
-          </a:xfrm>
-          <a:prstGeom prst="rect">
-            <a:avLst/>
-          </a:prstGeom>
-          <a:noFill/>
-        </p:spPr>
-        <p:txBody>
-          <a:bodyPr wrap="square" anchor="t">
-            <a:spAutoFit/>
-          </a:bodyPr>
-          <a:lstStyle/>
-          <a:p>
-            <a:pPr algn="ctr">
-              <a:spcBef>
-                <a:spcPts val="0"/>
-              </a:spcBef>
-              <a:spcAft>
-                <a:spcPts val="400"/>
-              </a:spcAft>
-            </a:pPr>
-            <a:r>
-              <a:rPr sz="1150" b="1" i="0">
-                <a:solidFill>
-                  <a:srgbClr val="FFFFFF"/>
-                </a:solidFill>
-                <a:latin typeface="Calibri"/>
-              </a:rPr>
-              <a:t>K1 Analyst Rating</a:t>
-            </a:r>
-          </a:p>
-        </p:txBody>
-      </p:sp>
-      <p:sp>
-        <p:nvSpPr>
-          <p:cNvPr id="20" name="TextBox 19"/>
-          <p:cNvSpPr txBox="1"/>
-          <p:nvPr/>
-        </p:nvSpPr>
-        <p:spPr>
-          <a:xfrm>
-            <a:off x="7772400" y="2670048"/>
-            <a:ext cx="3840480" cy="365760"/>
-          </a:xfrm>
-          <a:prstGeom prst="rect">
-            <a:avLst/>
-          </a:prstGeom>
-          <a:noFill/>
-        </p:spPr>
-        <p:txBody>
-          <a:bodyPr wrap="square" anchor="t">
-            <a:spAutoFit/>
-          </a:bodyPr>
-          <a:lstStyle/>
-          <a:p>
-            <a:pPr algn="l">
-              <a:spcBef>
-                <a:spcPts val="0"/>
-              </a:spcBef>
-              <a:spcAft>
-                <a:spcPts val="400"/>
-              </a:spcAft>
-            </a:pPr>
-            <a:r>
-              <a:rPr sz="1100" b="0" i="1">
-                <a:solidFill>
-                  <a:srgbClr val="6B7785"/>
-                </a:solidFill>
-                <a:latin typeface="Calibri"/>
-              </a:rPr>
-              <a:t>surprises trigger rating revisions</a:t>
-            </a:r>
-          </a:p>
-        </p:txBody>
-      </p:sp>
-      <p:sp>
-        <p:nvSpPr>
-          <p:cNvPr id="21" name="Rounded Rectangle 20"/>
-          <p:cNvSpPr/>
-          <p:nvPr/>
-        </p:nvSpPr>
-        <p:spPr>
-          <a:xfrm>
-            <a:off x="640080" y="3319272"/>
-            <a:ext cx="3108960" cy="548640"/>
-          </a:xfrm>
-          <a:prstGeom prst="roundRect">
-            <a:avLst/>
-          </a:prstGeom>
-          <a:solidFill>
-            <a:srgbClr val="1D3A5F"/>
-          </a:solidFill>
-          <a:ln>
-            <a:noFill/>
-          </a:ln>
-          <a:effectLst/>
-        </p:spPr>
-        <p:style>
-          <a:lnRef idx="1">
-            <a:schemeClr val="accent1"/>
-          </a:lnRef>
-          <a:fillRef idx="3">
-            <a:schemeClr val="accent1"/>
-          </a:fillRef>
-          <a:effectRef idx="2">
-            <a:schemeClr val="accent1"/>
-          </a:effectRef>
-          <a:fontRef idx="minor">
-            <a:schemeClr val="lt1"/>
-          </a:fontRef>
-        </p:style>
-        <p:txBody>
-          <a:bodyPr rtlCol="0" anchor="ctr"/>
-          <a:lstStyle/>
-          <a:p>
-            <a:pPr algn="ctr"/>
-          </a:p>
-        </p:txBody>
-      </p:sp>
-      <p:sp>
-        <p:nvSpPr>
-          <p:cNvPr id="22" name="TextBox 21"/>
-          <p:cNvSpPr txBox="1"/>
-          <p:nvPr/>
-        </p:nvSpPr>
-        <p:spPr>
-          <a:xfrm>
-            <a:off x="640080" y="3438144"/>
-            <a:ext cx="3108960" cy="365760"/>
-          </a:xfrm>
-          <a:prstGeom prst="rect">
-            <a:avLst/>
-          </a:prstGeom>
-          <a:noFill/>
-        </p:spPr>
-        <p:txBody>
-          <a:bodyPr wrap="square" anchor="t">
-            <a:spAutoFit/>
-          </a:bodyPr>
-          <a:lstStyle/>
-          <a:p>
-            <a:pPr algn="ctr">
-              <a:spcBef>
-                <a:spcPts val="0"/>
-              </a:spcBef>
-              <a:spcAft>
-                <a:spcPts val="400"/>
-              </a:spcAft>
-            </a:pPr>
-            <a:r>
-              <a:rPr sz="1150" b="1" i="0">
-                <a:solidFill>
-                  <a:srgbClr val="FFFFFF"/>
-                </a:solidFill>
-                <a:latin typeface="Calibri"/>
-              </a:rPr>
-              <a:t>C2 M&amp;A</a:t>
-            </a:r>
-          </a:p>
-        </p:txBody>
-      </p:sp>
-      <p:sp>
-        <p:nvSpPr>
-          <p:cNvPr id="23" name="TextBox 22"/>
-          <p:cNvSpPr txBox="1"/>
-          <p:nvPr/>
-        </p:nvSpPr>
-        <p:spPr>
-          <a:xfrm>
-            <a:off x="3794760" y="3410712"/>
-            <a:ext cx="640080" cy="365760"/>
-          </a:xfrm>
-          <a:prstGeom prst="rect">
-            <a:avLst/>
-          </a:prstGeom>
-          <a:noFill/>
-        </p:spPr>
-        <p:txBody>
-          <a:bodyPr wrap="square" anchor="t">
-            <a:spAutoFit/>
-          </a:bodyPr>
-          <a:lstStyle/>
-          <a:p>
-            <a:pPr algn="ctr">
-              <a:spcBef>
-                <a:spcPts val="0"/>
-              </a:spcBef>
-              <a:spcAft>
-                <a:spcPts val="400"/>
-              </a:spcAft>
-            </a:pPr>
-            <a:r>
-              <a:rPr sz="1800" b="1" i="0">
-                <a:solidFill>
-                  <a:srgbClr val="E3861F"/>
-                </a:solidFill>
-                <a:latin typeface="Calibri"/>
-              </a:rPr>
-              <a:t>→</a:t>
-            </a:r>
-          </a:p>
-        </p:txBody>
-      </p:sp>
-      <p:sp>
-        <p:nvSpPr>
-          <p:cNvPr id="24" name="Rounded Rectangle 23"/>
-          <p:cNvSpPr/>
-          <p:nvPr/>
-        </p:nvSpPr>
-        <p:spPr>
-          <a:xfrm>
-            <a:off x="4480560" y="3319272"/>
-            <a:ext cx="3108960" cy="548640"/>
-          </a:xfrm>
-          <a:prstGeom prst="roundRect">
-            <a:avLst/>
-          </a:prstGeom>
-          <a:solidFill>
-            <a:srgbClr val="2E6F9E"/>
-          </a:solidFill>
-          <a:ln>
-            <a:noFill/>
-          </a:ln>
-          <a:effectLst/>
-        </p:spPr>
-        <p:style>
-          <a:lnRef idx="1">
-            <a:schemeClr val="accent1"/>
-          </a:lnRef>
-          <a:fillRef idx="3">
-            <a:schemeClr val="accent1"/>
-          </a:fillRef>
-          <a:effectRef idx="2">
-            <a:schemeClr val="accent1"/>
-          </a:effectRef>
-          <a:fontRef idx="minor">
-            <a:schemeClr val="lt1"/>
-          </a:fontRef>
-        </p:style>
-        <p:txBody>
-          <a:bodyPr rtlCol="0" anchor="ctr"/>
-          <a:lstStyle/>
-          <a:p>
-            <a:pPr algn="ctr"/>
-          </a:p>
-        </p:txBody>
-      </p:sp>
-      <p:sp>
-        <p:nvSpPr>
-          <p:cNvPr id="25" name="TextBox 24"/>
-          <p:cNvSpPr txBox="1"/>
-          <p:nvPr/>
-        </p:nvSpPr>
-        <p:spPr>
-          <a:xfrm>
-            <a:off x="4480560" y="3438144"/>
-            <a:ext cx="3108960" cy="365760"/>
-          </a:xfrm>
-          <a:prstGeom prst="rect">
-            <a:avLst/>
-          </a:prstGeom>
-          <a:noFill/>
-        </p:spPr>
-        <p:txBody>
-          <a:bodyPr wrap="square" anchor="t">
-            <a:spAutoFit/>
-          </a:bodyPr>
-          <a:lstStyle/>
-          <a:p>
-            <a:pPr algn="ctr">
-              <a:spcBef>
-                <a:spcPts val="0"/>
-              </a:spcBef>
-              <a:spcAft>
-                <a:spcPts val="400"/>
-              </a:spcAft>
-            </a:pPr>
-            <a:r>
-              <a:rPr sz="1150" b="1" i="0">
-                <a:solidFill>
-                  <a:srgbClr val="FFFFFF"/>
-                </a:solidFill>
-                <a:latin typeface="Calibri"/>
-              </a:rPr>
-              <a:t>K1 Analyst Rating</a:t>
-            </a:r>
-          </a:p>
-        </p:txBody>
-      </p:sp>
-      <p:sp>
-        <p:nvSpPr>
-          <p:cNvPr id="26" name="TextBox 25"/>
-          <p:cNvSpPr txBox="1"/>
-          <p:nvPr/>
-        </p:nvSpPr>
-        <p:spPr>
-          <a:xfrm>
-            <a:off x="7772400" y="3438144"/>
-            <a:ext cx="3840480" cy="365760"/>
-          </a:xfrm>
-          <a:prstGeom prst="rect">
-            <a:avLst/>
-          </a:prstGeom>
-          <a:noFill/>
-        </p:spPr>
-        <p:txBody>
-          <a:bodyPr wrap="square" anchor="t">
-            <a:spAutoFit/>
-          </a:bodyPr>
-          <a:lstStyle/>
-          <a:p>
-            <a:pPr algn="l">
-              <a:spcBef>
-                <a:spcPts val="0"/>
-              </a:spcBef>
-              <a:spcAft>
-                <a:spcPts val="400"/>
-              </a:spcAft>
-            </a:pPr>
-            <a:r>
-              <a:rPr sz="1100" b="0" i="1">
-                <a:solidFill>
-                  <a:srgbClr val="6B7785"/>
-                </a:solidFill>
-                <a:latin typeface="Calibri"/>
-              </a:rPr>
-              <a:t>deals re-rate the merged entity</a:t>
-            </a:r>
-          </a:p>
-        </p:txBody>
-      </p:sp>
-      <p:sp>
-        <p:nvSpPr>
-          <p:cNvPr id="27" name="Rounded Rectangle 26"/>
-          <p:cNvSpPr/>
-          <p:nvPr/>
-        </p:nvSpPr>
-        <p:spPr>
-          <a:xfrm>
-            <a:off x="640080" y="4087368"/>
-            <a:ext cx="3108960" cy="548640"/>
-          </a:xfrm>
-          <a:prstGeom prst="roundRect">
-            <a:avLst/>
-          </a:prstGeom>
-          <a:solidFill>
-            <a:srgbClr val="1D3A5F"/>
-          </a:solidFill>
-          <a:ln>
-            <a:noFill/>
-          </a:ln>
-          <a:effectLst/>
-        </p:spPr>
-        <p:style>
-          <a:lnRef idx="1">
-            <a:schemeClr val="accent1"/>
-          </a:lnRef>
-          <a:fillRef idx="3">
-            <a:schemeClr val="accent1"/>
-          </a:fillRef>
-          <a:effectRef idx="2">
-            <a:schemeClr val="accent1"/>
-          </a:effectRef>
-          <a:fontRef idx="minor">
-            <a:schemeClr val="lt1"/>
-          </a:fontRef>
-        </p:style>
-        <p:txBody>
-          <a:bodyPr rtlCol="0" anchor="ctr"/>
-          <a:lstStyle/>
-          <a:p>
-            <a:pPr algn="ctr"/>
-          </a:p>
-        </p:txBody>
-      </p:sp>
-      <p:sp>
-        <p:nvSpPr>
-          <p:cNvPr id="28" name="TextBox 27"/>
-          <p:cNvSpPr txBox="1"/>
-          <p:nvPr/>
-        </p:nvSpPr>
-        <p:spPr>
-          <a:xfrm>
-            <a:off x="640080" y="4206240"/>
-            <a:ext cx="3108960" cy="365760"/>
-          </a:xfrm>
-          <a:prstGeom prst="rect">
-            <a:avLst/>
-          </a:prstGeom>
-          <a:noFill/>
-        </p:spPr>
-        <p:txBody>
-          <a:bodyPr wrap="square" anchor="t">
-            <a:spAutoFit/>
-          </a:bodyPr>
-          <a:lstStyle/>
-          <a:p>
-            <a:pPr algn="ctr">
-              <a:spcBef>
-                <a:spcPts val="0"/>
-              </a:spcBef>
-              <a:spcAft>
-                <a:spcPts val="400"/>
-              </a:spcAft>
-            </a:pPr>
-            <a:r>
-              <a:rPr sz="1150" b="1" i="0">
-                <a:solidFill>
-                  <a:srgbClr val="FFFFFF"/>
-                </a:solidFill>
-                <a:latin typeface="Calibri"/>
-              </a:rPr>
-              <a:t>M4 Monetary Signal</a:t>
-            </a:r>
-          </a:p>
-        </p:txBody>
-      </p:sp>
-      <p:sp>
-        <p:nvSpPr>
-          <p:cNvPr id="29" name="TextBox 28"/>
-          <p:cNvSpPr txBox="1"/>
-          <p:nvPr/>
-        </p:nvSpPr>
-        <p:spPr>
-          <a:xfrm>
-            <a:off x="3794760" y="4178807"/>
-            <a:ext cx="640080" cy="365760"/>
-          </a:xfrm>
-          <a:prstGeom prst="rect">
-            <a:avLst/>
-          </a:prstGeom>
-          <a:noFill/>
-        </p:spPr>
-        <p:txBody>
-          <a:bodyPr wrap="square" anchor="t">
-            <a:spAutoFit/>
-          </a:bodyPr>
-          <a:lstStyle/>
-          <a:p>
-            <a:pPr algn="ctr">
-              <a:spcBef>
-                <a:spcPts val="0"/>
-              </a:spcBef>
-              <a:spcAft>
-                <a:spcPts val="400"/>
-              </a:spcAft>
-            </a:pPr>
-            <a:r>
-              <a:rPr sz="1800" b="1" i="0">
-                <a:solidFill>
-                  <a:srgbClr val="E3861F"/>
-                </a:solidFill>
-                <a:latin typeface="Calibri"/>
-              </a:rPr>
-              <a:t>→</a:t>
-            </a:r>
-          </a:p>
-        </p:txBody>
-      </p:sp>
-      <p:sp>
-        <p:nvSpPr>
-          <p:cNvPr id="30" name="Rounded Rectangle 29"/>
-          <p:cNvSpPr/>
-          <p:nvPr/>
-        </p:nvSpPr>
-        <p:spPr>
-          <a:xfrm>
-            <a:off x="4480560" y="4087368"/>
-            <a:ext cx="3108960" cy="548640"/>
-          </a:xfrm>
-          <a:prstGeom prst="roundRect">
-            <a:avLst/>
-          </a:prstGeom>
-          <a:solidFill>
-            <a:srgbClr val="2E6F9E"/>
-          </a:solidFill>
-          <a:ln>
-            <a:noFill/>
-          </a:ln>
-          <a:effectLst/>
-        </p:spPr>
-        <p:style>
-          <a:lnRef idx="1">
-            <a:schemeClr val="accent1"/>
-          </a:lnRef>
-          <a:fillRef idx="3">
-            <a:schemeClr val="accent1"/>
-          </a:fillRef>
-          <a:effectRef idx="2">
-            <a:schemeClr val="accent1"/>
-          </a:effectRef>
-          <a:fontRef idx="minor">
-            <a:schemeClr val="lt1"/>
-          </a:fontRef>
-        </p:style>
-        <p:txBody>
-          <a:bodyPr rtlCol="0" anchor="ctr"/>
-          <a:lstStyle/>
-          <a:p>
-            <a:pPr algn="ctr"/>
-          </a:p>
-        </p:txBody>
-      </p:sp>
-      <p:sp>
-        <p:nvSpPr>
-          <p:cNvPr id="31" name="TextBox 30"/>
-          <p:cNvSpPr txBox="1"/>
-          <p:nvPr/>
-        </p:nvSpPr>
-        <p:spPr>
-          <a:xfrm>
-            <a:off x="4480560" y="4206240"/>
-            <a:ext cx="3108960" cy="365760"/>
-          </a:xfrm>
-          <a:prstGeom prst="rect">
-            <a:avLst/>
-          </a:prstGeom>
-          <a:noFill/>
-        </p:spPr>
-        <p:txBody>
-          <a:bodyPr wrap="square" anchor="t">
-            <a:spAutoFit/>
-          </a:bodyPr>
-          <a:lstStyle/>
-          <a:p>
-            <a:pPr algn="ctr">
-              <a:spcBef>
-                <a:spcPts val="0"/>
-              </a:spcBef>
-              <a:spcAft>
-                <a:spcPts val="400"/>
-              </a:spcAft>
-            </a:pPr>
-            <a:r>
-              <a:rPr sz="1150" b="1" i="0">
-                <a:solidFill>
-                  <a:srgbClr val="FFFFFF"/>
-                </a:solidFill>
-                <a:latin typeface="Calibri"/>
-              </a:rPr>
-              <a:t>M1 Interest Rate</a:t>
-            </a:r>
-          </a:p>
-        </p:txBody>
-      </p:sp>
-      <p:sp>
-        <p:nvSpPr>
-          <p:cNvPr id="32" name="TextBox 31"/>
-          <p:cNvSpPr txBox="1"/>
-          <p:nvPr/>
-        </p:nvSpPr>
-        <p:spPr>
-          <a:xfrm>
-            <a:off x="7772400" y="4206240"/>
-            <a:ext cx="3840480" cy="365760"/>
-          </a:xfrm>
-          <a:prstGeom prst="rect">
-            <a:avLst/>
-          </a:prstGeom>
-          <a:noFill/>
-        </p:spPr>
-        <p:txBody>
-          <a:bodyPr wrap="square" anchor="t">
-            <a:spAutoFit/>
-          </a:bodyPr>
-          <a:lstStyle/>
-          <a:p>
-            <a:pPr algn="l">
-              <a:spcBef>
-                <a:spcPts val="0"/>
-              </a:spcBef>
-              <a:spcAft>
-                <a:spcPts val="400"/>
-              </a:spcAft>
-            </a:pPr>
-            <a:r>
-              <a:rPr sz="1100" b="0" i="1">
-                <a:solidFill>
-                  <a:srgbClr val="6B7785"/>
-                </a:solidFill>
-                <a:latin typeface="Calibri"/>
-              </a:rPr>
-              <a:t>signaling precedes hikes</a:t>
-            </a:r>
-          </a:p>
-        </p:txBody>
-      </p:sp>
-      <p:sp>
-        <p:nvSpPr>
-          <p:cNvPr id="33" name="Rounded Rectangle 32"/>
-          <p:cNvSpPr/>
-          <p:nvPr/>
-        </p:nvSpPr>
-        <p:spPr>
-          <a:xfrm>
-            <a:off x="548640" y="5029200"/>
-            <a:ext cx="11109960" cy="1325880"/>
+            <a:off x="548640" y="5852160"/>
+            <a:ext cx="11155680" cy="658368"/>
           </a:xfrm>
           <a:prstGeom prst="roundRect">
             <a:avLst/>
@@ -8509,14 +7742,14 @@
       </p:sp>
       <p:sp>
         <p:nvSpPr>
-          <p:cNvPr id="34" name="TextBox 33"/>
-          <p:cNvSpPr txBox="1"/>
-          <p:nvPr/>
-        </p:nvSpPr>
-        <p:spPr>
-          <a:xfrm>
-            <a:off x="822960" y="5175504"/>
-            <a:ext cx="10515600" cy="411480"/>
+          <p:cNvPr id="14" name="TextBox 13"/>
+          <p:cNvSpPr txBox="1"/>
+          <p:nvPr/>
+        </p:nvSpPr>
+        <p:spPr>
+          <a:xfrm>
+            <a:off x="822960" y="5980176"/>
+            <a:ext cx="10607040" cy="457200"/>
           </a:xfrm>
           <a:prstGeom prst="rect">
             <a:avLst/>
@@ -8538,58 +7771,22 @@
               </a:spcAft>
             </a:pPr>
             <a:r>
-              <a:rPr sz="1250" b="1" i="0">
-                <a:solidFill>
-                  <a:srgbClr val="C2492F"/>
-                </a:solidFill>
-                <a:latin typeface="Calibri"/>
-              </a:rPr>
-              <a:t>Honesty note</a:t>
-            </a:r>
-          </a:p>
-        </p:txBody>
-      </p:sp>
-      <p:sp>
-        <p:nvSpPr>
-          <p:cNvPr id="35" name="TextBox 34"/>
-          <p:cNvSpPr txBox="1"/>
-          <p:nvPr/>
-        </p:nvSpPr>
-        <p:spPr>
-          <a:xfrm>
-            <a:off x="822960" y="5522976"/>
-            <a:ext cx="10561320" cy="777240"/>
-          </a:xfrm>
-          <a:prstGeom prst="rect">
-            <a:avLst/>
-          </a:prstGeom>
-          <a:noFill/>
-        </p:spPr>
-        <p:txBody>
-          <a:bodyPr wrap="square" anchor="t">
-            <a:spAutoFit/>
-          </a:bodyPr>
-          <a:lstStyle/>
-          <a:p>
-            <a:pPr algn="l">
-              <a:lnSpc>
-                <a:spcPct val="113000"/>
-              </a:lnSpc>
-              <a:spcBef>
-                <a:spcPts val="0"/>
-              </a:spcBef>
-              <a:spcAft>
-                <a:spcPts val="400"/>
-              </a:spcAft>
-            </a:pPr>
-            <a:r>
-              <a:rPr sz="1100" b="0" i="0">
+              <a:rPr sz="1150" b="1" i="0">
+                <a:solidFill>
+                  <a:srgbClr val="1D3A5F"/>
+                </a:solidFill>
+                <a:latin typeface="Calibri"/>
+              </a:rPr>
+              <a:t>Honest takeaway:  </a:t>
+            </a:r>
+            <a:r>
+              <a:rPr sz="1150" b="0" i="0">
                 <a:solidFill>
                   <a:srgbClr val="243748"/>
                 </a:solidFill>
                 <a:latin typeface="Calibri"/>
               </a:rPr>
-              <a:t>Chains above are the structure the framework is designed to surface. The final 20×20 matrix must be exported from the trained STACD model (export_model_figures.py); A is directed predictive temporal dependence under time-ordering + sparsity + DAG — not intervention-level causality.</a:t>
+              <a:t>end-to-end causal discovery is not identifiable on a low-signal target — next step: estimate the graph from observed lagged co-occurrence.</a:t>
             </a:r>
           </a:p>
         </p:txBody>
@@ -11696,7 +10893,7 @@
                 </a:solidFill>
                 <a:latin typeface="Calibri"/>
               </a:rPr>
-              <a:t>EDA-driven attribute design is the strongest interpretability lever.</a:t>
+              <a:t>EDA-driven attribute design is the strongest, most defensible contribution.</a:t>
             </a:r>
           </a:p>
           <a:p>
@@ -11727,7 +10924,7 @@
                 </a:solidFill>
                 <a:latin typeface="Calibri"/>
               </a:rPr>
-              <a:t>Event-type graph captures intuitive chains (rate→earnings).</a:t>
+              <a:t>Three negative results share one cause — the weak forward-time signal.</a:t>
             </a:r>
           </a:p>
           <a:p>
@@ -11942,7 +11139,7 @@
                 </a:solidFill>
                 <a:latin typeface="Calibri"/>
               </a:rPr>
-              <a:t>A is predictive temporal dependence, not intervention causality.</a:t>
+              <a:t>End-to-end causal discovery did not learn — graph stays at initialization.</a:t>
             </a:r>
           </a:p>
           <a:p>
@@ -11973,7 +11170,7 @@
                 </a:solidFill>
                 <a:latin typeface="Calibri"/>
               </a:rPr>
-              <a:t>Neural-ODE propagation underperforms — low-SNR daily data, high-capacity continuous-time models fit noise.</a:t>
+              <a:t>Neural-ODE propagation overfits — low-SNR daily data, high-capacity continuous-time models fit noise.</a:t>
             </a:r>
           </a:p>
           <a:p>
@@ -12188,7 +11385,7 @@
                 </a:solidFill>
                 <a:latin typeface="Calibri"/>
               </a:rPr>
-              <a:t>Multi-seed confidence intervals; MCC / IC metrics.</a:t>
+              <a:t>Event-type graph from lagged co-occurrence (no end-to-end gradient).</a:t>
             </a:r>
           </a:p>
           <a:p>
@@ -12219,7 +11416,7 @@
                 </a:solidFill>
                 <a:latin typeface="Calibri"/>
               </a:rPr>
-              <a:t>Rolling walk-forward validation as the default.</a:t>
+              <a:t>Multi-seed confidence intervals; rolling walk-forward validation.</a:t>
             </a:r>
           </a:p>
           <a:p>
@@ -12250,7 +11447,7 @@
                 </a:solidFill>
                 <a:latin typeface="Calibri"/>
               </a:rPr>
-              <a:t>Train &amp; export the real causal graph; LLM-assisted surprise.</a:t>
+              <a:t>LLM-assisted surprise extraction to lift its 6.6% coverage.</a:t>
             </a:r>
           </a:p>
         </p:txBody>

</xml_diff>